<commit_message>
Corrige nombre de integrante y nota final del informe
</commit_message>
<xml_diff>
--- a/docs/Estabilidad de la agenda temática de la prensa colombiana (1980–2011).pptx
+++ b/docs/Estabilidad de la agenda temática de la prensa colombiana (1980–2011).pptx
@@ -2,24 +2,24 @@
 <file path=ppt/presentation.xml><?xml version="1.0" encoding="utf-8"?>
 <p:presentation xmlns:p="http://schemas.openxmlformats.org/presentationml/2006/main">
   <p:sldMasterIdLst>
-    <p:sldMasterId xmlns:r="http://schemas.openxmlformats.org/officeDocument/2006/relationships" id="2147483648" r:id="Re40a67c9316e48a4"/>
+    <p:sldMasterId xmlns:r="http://schemas.openxmlformats.org/officeDocument/2006/relationships" id="2147483648" r:id="R2ce011502e354f89"/>
   </p:sldMasterIdLst>
   <p:notesMasterIdLst>
-    <p:notesMasterId xmlns:r="http://schemas.openxmlformats.org/officeDocument/2006/relationships" r:id="Ra55e3350c9f34397"/>
+    <p:notesMasterId xmlns:r="http://schemas.openxmlformats.org/officeDocument/2006/relationships" r:id="R30963bb56e2d48ab"/>
   </p:notesMasterIdLst>
   <p:sldIdLst>
-    <p:sldId xmlns:r="http://schemas.openxmlformats.org/officeDocument/2006/relationships" id="256" r:id="R2e9691901029411d"/>
-    <p:sldId xmlns:r="http://schemas.openxmlformats.org/officeDocument/2006/relationships" id="257" r:id="Rf6a9c8008a7844e4"/>
-    <p:sldId xmlns:r="http://schemas.openxmlformats.org/officeDocument/2006/relationships" id="258" r:id="R6d319a8393484231"/>
-    <p:sldId xmlns:r="http://schemas.openxmlformats.org/officeDocument/2006/relationships" id="259" r:id="R089593a3e4d447ae"/>
-    <p:sldId xmlns:r="http://schemas.openxmlformats.org/officeDocument/2006/relationships" id="260" r:id="R0ecb86a1417f40f8"/>
-    <p:sldId xmlns:r="http://schemas.openxmlformats.org/officeDocument/2006/relationships" id="261" r:id="R61b0e4e85ae84220"/>
-    <p:sldId xmlns:r="http://schemas.openxmlformats.org/officeDocument/2006/relationships" id="262" r:id="R64dfbb4b33fc43e6"/>
-    <p:sldId xmlns:r="http://schemas.openxmlformats.org/officeDocument/2006/relationships" id="263" r:id="R011f682703484cc7"/>
-    <p:sldId xmlns:r="http://schemas.openxmlformats.org/officeDocument/2006/relationships" id="264" r:id="Rfca5a01f3f304036"/>
-    <p:sldId xmlns:r="http://schemas.openxmlformats.org/officeDocument/2006/relationships" id="265" r:id="Rbe6928d75e014f12"/>
-    <p:sldId xmlns:r="http://schemas.openxmlformats.org/officeDocument/2006/relationships" id="266" r:id="Rba3ca98ee4294235"/>
-    <p:sldId xmlns:r="http://schemas.openxmlformats.org/officeDocument/2006/relationships" id="267" r:id="R7c634df9383045e5"/>
+    <p:sldId xmlns:r="http://schemas.openxmlformats.org/officeDocument/2006/relationships" id="256" r:id="R48db298c95024808"/>
+    <p:sldId xmlns:r="http://schemas.openxmlformats.org/officeDocument/2006/relationships" id="257" r:id="R38fc0736a802449a"/>
+    <p:sldId xmlns:r="http://schemas.openxmlformats.org/officeDocument/2006/relationships" id="258" r:id="Rc087380aa39c41b4"/>
+    <p:sldId xmlns:r="http://schemas.openxmlformats.org/officeDocument/2006/relationships" id="259" r:id="R9db740eb5ca443b3"/>
+    <p:sldId xmlns:r="http://schemas.openxmlformats.org/officeDocument/2006/relationships" id="260" r:id="R63c4cbb054c54f37"/>
+    <p:sldId xmlns:r="http://schemas.openxmlformats.org/officeDocument/2006/relationships" id="261" r:id="Rd123e8c8639445df"/>
+    <p:sldId xmlns:r="http://schemas.openxmlformats.org/officeDocument/2006/relationships" id="262" r:id="R679c1fc39fb14d74"/>
+    <p:sldId xmlns:r="http://schemas.openxmlformats.org/officeDocument/2006/relationships" id="263" r:id="Rddde0d54ed9c446e"/>
+    <p:sldId xmlns:r="http://schemas.openxmlformats.org/officeDocument/2006/relationships" id="264" r:id="R0a0a3f2f30e94e13"/>
+    <p:sldId xmlns:r="http://schemas.openxmlformats.org/officeDocument/2006/relationships" id="265" r:id="R5e88fb2613314350"/>
+    <p:sldId xmlns:r="http://schemas.openxmlformats.org/officeDocument/2006/relationships" id="266" r:id="R82237b6f119e4dd6"/>
+    <p:sldId xmlns:r="http://schemas.openxmlformats.org/officeDocument/2006/relationships" id="267" r:id="R6cc3fc30e86b4a76"/>
   </p:sldIdLst>
   <p:sldSz cx="12192000" cy="6858000"/>
   <p:notesSz cx="6858000" cy="9144000"/>
@@ -1950,7 +1950,7 @@
           <p:cNvPr id="3" name="Title">
             <a:extLst xmlns:a="http://schemas.openxmlformats.org/drawingml/2006/main">
               <a:ext uri="{FF2B5EF4-FFF2-40B4-BE49-F238E27FC236}">
-                <a16:creationId xmlns:a16="http://schemas.microsoft.com/office/drawing/2014/main" id="{2CECBDAD-90F7-43E3-BE76-6AD73859B324}"/>
+                <a16:creationId xmlns:a16="http://schemas.microsoft.com/office/drawing/2014/main" id="{9B0429C5-663C-45BF-98D8-54E92E77C5E2}"/>
               </a:ext>
             </a:extLst>
           </p:cNvPr>
@@ -2107,7 +2107,7 @@
           <p:cNvPr id="2" name="Subtitle">
             <a:extLst xmlns:a="http://schemas.openxmlformats.org/drawingml/2006/main">
               <a:ext uri="{FF2B5EF4-FFF2-40B4-BE49-F238E27FC236}">
-                <a16:creationId xmlns:a16="http://schemas.microsoft.com/office/drawing/2014/main" id="{2AD4D70E-B3D9-43BD-943D-403169D08882}"/>
+                <a16:creationId xmlns:a16="http://schemas.microsoft.com/office/drawing/2014/main" id="{5D38695F-E35D-4CE0-BF8E-944860A46384}"/>
               </a:ext>
             </a:extLst>
           </p:cNvPr>
@@ -2281,7 +2281,7 @@
           <p:cNvPr id="2" name="Section title">
             <a:extLst xmlns:a="http://schemas.openxmlformats.org/drawingml/2006/main">
               <a:ext uri="{FF2B5EF4-FFF2-40B4-BE49-F238E27FC236}">
-                <a16:creationId xmlns:a16="http://schemas.microsoft.com/office/drawing/2014/main" id="{B33BF39F-F165-4448-A38E-0409C2E384CE}"/>
+                <a16:creationId xmlns:a16="http://schemas.microsoft.com/office/drawing/2014/main" id="{08D1C527-60F8-4F60-875A-2CE4BB093BC0}"/>
               </a:ext>
             </a:extLst>
           </p:cNvPr>
@@ -2455,7 +2455,7 @@
           <p:cNvPr id="3" name="Title">
             <a:extLst xmlns:a="http://schemas.openxmlformats.org/drawingml/2006/main">
               <a:ext uri="{FF2B5EF4-FFF2-40B4-BE49-F238E27FC236}">
-                <a16:creationId xmlns:a16="http://schemas.microsoft.com/office/drawing/2014/main" id="{4A91B21B-BD97-4107-A999-C8532DB9C1A1}"/>
+                <a16:creationId xmlns:a16="http://schemas.microsoft.com/office/drawing/2014/main" id="{AC0E5F1D-235A-47B8-89AF-58DC5EB3D689}"/>
               </a:ext>
             </a:extLst>
           </p:cNvPr>
@@ -2612,7 +2612,7 @@
           <p:cNvPr id="2" name="Body">
             <a:extLst xmlns:a="http://schemas.openxmlformats.org/drawingml/2006/main">
               <a:ext uri="{FF2B5EF4-FFF2-40B4-BE49-F238E27FC236}">
-                <a16:creationId xmlns:a16="http://schemas.microsoft.com/office/drawing/2014/main" id="{0913A649-6426-4F1A-A733-4F5ACE7213A1}"/>
+                <a16:creationId xmlns:a16="http://schemas.microsoft.com/office/drawing/2014/main" id="{7CD9C2F9-4D7B-4AB7-996C-5B238390D3BC}"/>
               </a:ext>
             </a:extLst>
           </p:cNvPr>
@@ -2786,7 +2786,7 @@
           <p:cNvPr id="4" name="Title">
             <a:extLst xmlns:a="http://schemas.openxmlformats.org/drawingml/2006/main">
               <a:ext uri="{FF2B5EF4-FFF2-40B4-BE49-F238E27FC236}">
-                <a16:creationId xmlns:a16="http://schemas.microsoft.com/office/drawing/2014/main" id="{C4D97D89-FAEA-4B0A-8722-3C1D08B4C8D4}"/>
+                <a16:creationId xmlns:a16="http://schemas.microsoft.com/office/drawing/2014/main" id="{5CD87A91-1ADF-4B51-AF30-7B9BAF13DB2D}"/>
               </a:ext>
             </a:extLst>
           </p:cNvPr>
@@ -2943,7 +2943,7 @@
           <p:cNvPr id="2" name="Left column">
             <a:extLst xmlns:a="http://schemas.openxmlformats.org/drawingml/2006/main">
               <a:ext uri="{FF2B5EF4-FFF2-40B4-BE49-F238E27FC236}">
-                <a16:creationId xmlns:a16="http://schemas.microsoft.com/office/drawing/2014/main" id="{82AE7944-9B5F-4D56-BA47-6C4FCB75315E}"/>
+                <a16:creationId xmlns:a16="http://schemas.microsoft.com/office/drawing/2014/main" id="{3051B133-5EE5-417A-A91B-66D52F13EE49}"/>
               </a:ext>
             </a:extLst>
           </p:cNvPr>
@@ -3100,7 +3100,7 @@
           <p:cNvPr id="3" name="Right column">
             <a:extLst xmlns:a="http://schemas.openxmlformats.org/drawingml/2006/main">
               <a:ext uri="{FF2B5EF4-FFF2-40B4-BE49-F238E27FC236}">
-                <a16:creationId xmlns:a16="http://schemas.microsoft.com/office/drawing/2014/main" id="{F1F13451-417B-48CC-B583-0B8D3F2EED2B}"/>
+                <a16:creationId xmlns:a16="http://schemas.microsoft.com/office/drawing/2014/main" id="{36D79DC1-BCFF-4F92-B11F-E02BC4FD2AFC}"/>
               </a:ext>
             </a:extLst>
           </p:cNvPr>
@@ -3274,7 +3274,7 @@
           <p:cNvPr id="3" name="Title">
             <a:extLst xmlns:a="http://schemas.openxmlformats.org/drawingml/2006/main">
               <a:ext uri="{FF2B5EF4-FFF2-40B4-BE49-F238E27FC236}">
-                <a16:creationId xmlns:a16="http://schemas.microsoft.com/office/drawing/2014/main" id="{1A8EABCC-26E4-4AE5-8E72-7FAA5C8E138D}"/>
+                <a16:creationId xmlns:a16="http://schemas.microsoft.com/office/drawing/2014/main" id="{C0363229-D438-4681-8C86-DA20F21E0477}"/>
               </a:ext>
             </a:extLst>
           </p:cNvPr>
@@ -3431,7 +3431,7 @@
           <p:cNvPr id="2" name="Left column">
             <a:extLst xmlns:a="http://schemas.openxmlformats.org/drawingml/2006/main">
               <a:ext uri="{FF2B5EF4-FFF2-40B4-BE49-F238E27FC236}">
-                <a16:creationId xmlns:a16="http://schemas.microsoft.com/office/drawing/2014/main" id="{71A78E7D-77EE-4F66-8D6B-BEC29E5E10F1}"/>
+                <a16:creationId xmlns:a16="http://schemas.microsoft.com/office/drawing/2014/main" id="{ED834E04-4557-4997-875B-997C322F2007}"/>
               </a:ext>
             </a:extLst>
           </p:cNvPr>
@@ -3626,12 +3626,12 @@
   </p:cSld>
   <p:clrMap bg1="lt1" tx1="dk1" bg2="lt2" tx2="dk2" accent1="accent1" accent2="accent2" accent3="accent3" accent4="accent4" accent5="accent5" accent6="accent6" hlink="hlink" folHlink="folHlink"/>
   <p:sldLayoutIdLst>
-    <p:sldLayoutId xmlns:r="http://schemas.openxmlformats.org/officeDocument/2006/relationships" id="2147483649" r:id="R01bf6bc3668e463d"/>
-    <p:sldLayoutId xmlns:r="http://schemas.openxmlformats.org/officeDocument/2006/relationships" id="2147483650" r:id="R24cb3ce31ca4476e"/>
-    <p:sldLayoutId xmlns:r="http://schemas.openxmlformats.org/officeDocument/2006/relationships" id="2147483651" r:id="Rc317948112ba427f"/>
-    <p:sldLayoutId xmlns:r="http://schemas.openxmlformats.org/officeDocument/2006/relationships" id="2147483652" r:id="Rf05e356e8b284dd3"/>
-    <p:sldLayoutId xmlns:r="http://schemas.openxmlformats.org/officeDocument/2006/relationships" id="2147483653" r:id="Rc8dc1808a0564f11"/>
-    <p:sldLayoutId xmlns:r="http://schemas.openxmlformats.org/officeDocument/2006/relationships" id="2147483654" r:id="R78e0e282b02f4afa"/>
+    <p:sldLayoutId xmlns:r="http://schemas.openxmlformats.org/officeDocument/2006/relationships" id="2147483649" r:id="R6e676ef3f6644722"/>
+    <p:sldLayoutId xmlns:r="http://schemas.openxmlformats.org/officeDocument/2006/relationships" id="2147483650" r:id="R6973e6a0e7f8463a"/>
+    <p:sldLayoutId xmlns:r="http://schemas.openxmlformats.org/officeDocument/2006/relationships" id="2147483651" r:id="R175c487799ae46c4"/>
+    <p:sldLayoutId xmlns:r="http://schemas.openxmlformats.org/officeDocument/2006/relationships" id="2147483652" r:id="R2995fb69aa554df9"/>
+    <p:sldLayoutId xmlns:r="http://schemas.openxmlformats.org/officeDocument/2006/relationships" id="2147483653" r:id="Rdc2380d7d0a8469c"/>
+    <p:sldLayoutId xmlns:r="http://schemas.openxmlformats.org/officeDocument/2006/relationships" id="2147483654" r:id="R41bb4951a44348f9"/>
   </p:sldLayoutIdLst>
   <p:txStyles>
     <p:titleStyle>
@@ -6219,7 +6219,7 @@
           <p:cNvPr id="10" name="">
             <a:extLst xmlns:a="http://schemas.openxmlformats.org/drawingml/2006/main">
               <a:ext uri="{FF2B5EF4-FFF2-40B4-BE49-F238E27FC236}">
-                <a16:creationId xmlns:a16="http://schemas.microsoft.com/office/drawing/2014/main" id="{A2E05AC2-B143-4685-93F0-DA2F125E8078}"/>
+                <a16:creationId xmlns:a16="http://schemas.microsoft.com/office/drawing/2014/main" id="{ADC3AB81-57AC-44A9-9121-57BFFA0EEDCA}"/>
               </a:ext>
             </a:extLst>
           </p:cNvPr>
@@ -6249,7 +6249,7 @@
           <p:cNvPr id="2" name="">
             <a:extLst xmlns:a="http://schemas.openxmlformats.org/drawingml/2006/main">
               <a:ext uri="{FF2B5EF4-FFF2-40B4-BE49-F238E27FC236}">
-                <a16:creationId xmlns:a16="http://schemas.microsoft.com/office/drawing/2014/main" id="{5333BEC4-6FC0-4963-A96B-61DC53F3624D}"/>
+                <a16:creationId xmlns:a16="http://schemas.microsoft.com/office/drawing/2014/main" id="{B6A7FD60-731F-4362-AA87-37CA864B3AE2}"/>
               </a:ext>
             </a:extLst>
           </p:cNvPr>
@@ -6317,7 +6317,7 @@
           <p:cNvPr id="3" name="">
             <a:extLst xmlns:a="http://schemas.openxmlformats.org/drawingml/2006/main">
               <a:ext uri="{FF2B5EF4-FFF2-40B4-BE49-F238E27FC236}">
-                <a16:creationId xmlns:a16="http://schemas.microsoft.com/office/drawing/2014/main" id="{1E6CD3E3-E1BC-4B87-AF74-0B3FED8F23F5}"/>
+                <a16:creationId xmlns:a16="http://schemas.microsoft.com/office/drawing/2014/main" id="{8BACEB71-24D7-44E4-9A37-BBBDA9496DA3}"/>
               </a:ext>
             </a:extLst>
           </p:cNvPr>
@@ -6327,7 +6327,7 @@
           <p:nvPr/>
         </p:nvPicPr>
         <p:blipFill>
-          <a:blip xmlns:r="http://schemas.openxmlformats.org/officeDocument/2006/relationships" xmlns:a="http://schemas.openxmlformats.org/drawingml/2006/main" r:embed="Rf83ef93c5f0e4e14"/>
+          <a:blip xmlns:r="http://schemas.openxmlformats.org/officeDocument/2006/relationships" xmlns:a="http://schemas.openxmlformats.org/drawingml/2006/main" r:embed="Rce22c78baff44f6b"/>
           <a:srcRect xmlns:a="http://schemas.openxmlformats.org/drawingml/2006/main" l="0" t="98" r="0" b="98"/>
           <a:stretch xmlns:a="http://schemas.openxmlformats.org/drawingml/2006/main">
             <a:fillRect l="0" t="0" r="0" b="0"/>
@@ -6348,7 +6348,7 @@
           <p:cNvPr id="4" name="">
             <a:extLst xmlns:a="http://schemas.openxmlformats.org/drawingml/2006/main">
               <a:ext uri="{FF2B5EF4-FFF2-40B4-BE49-F238E27FC236}">
-                <a16:creationId xmlns:a16="http://schemas.microsoft.com/office/drawing/2014/main" id="{DB05A08E-AA8A-47FE-A893-8E299B4BE7A7}"/>
+                <a16:creationId xmlns:a16="http://schemas.microsoft.com/office/drawing/2014/main" id="{EEE917DC-6AC7-4DF6-A72A-3380FB3F3914}"/>
               </a:ext>
             </a:extLst>
           </p:cNvPr>
@@ -6416,7 +6416,7 @@
           <p:cNvPr id="5" name="">
             <a:extLst xmlns:a="http://schemas.openxmlformats.org/drawingml/2006/main">
               <a:ext uri="{FF2B5EF4-FFF2-40B4-BE49-F238E27FC236}">
-                <a16:creationId xmlns:a16="http://schemas.microsoft.com/office/drawing/2014/main" id="{63CB5762-6922-48E2-85B4-1AB7AEF47971}"/>
+                <a16:creationId xmlns:a16="http://schemas.microsoft.com/office/drawing/2014/main" id="{841EE3AA-D5A5-43F5-9E35-F4EF741E8B6A}"/>
               </a:ext>
             </a:extLst>
           </p:cNvPr>
@@ -6507,7 +6507,7 @@
           <p:cNvPr id="6" name="">
             <a:extLst xmlns:a="http://schemas.openxmlformats.org/drawingml/2006/main">
               <a:ext uri="{FF2B5EF4-FFF2-40B4-BE49-F238E27FC236}">
-                <a16:creationId xmlns:a16="http://schemas.microsoft.com/office/drawing/2014/main" id="{E9836D00-B8D9-4FAF-A5C6-8880C697345F}"/>
+                <a16:creationId xmlns:a16="http://schemas.microsoft.com/office/drawing/2014/main" id="{02B0F188-FF44-4261-975F-7886AFC7BF55}"/>
               </a:ext>
             </a:extLst>
           </p:cNvPr>
@@ -6575,7 +6575,7 @@
           <p:cNvPr id="7" name="">
             <a:extLst xmlns:a="http://schemas.openxmlformats.org/drawingml/2006/main">
               <a:ext uri="{FF2B5EF4-FFF2-40B4-BE49-F238E27FC236}">
-                <a16:creationId xmlns:a16="http://schemas.microsoft.com/office/drawing/2014/main" id="{4D9A3257-6486-4EFE-B982-C409899FD3E7}"/>
+                <a16:creationId xmlns:a16="http://schemas.microsoft.com/office/drawing/2014/main" id="{85C266CC-B128-4768-B542-37A45F2C01BF}"/>
               </a:ext>
             </a:extLst>
           </p:cNvPr>
@@ -6643,7 +6643,7 @@
           <p:cNvPr id="8" name="">
             <a:extLst xmlns:a="http://schemas.openxmlformats.org/drawingml/2006/main">
               <a:ext uri="{FF2B5EF4-FFF2-40B4-BE49-F238E27FC236}">
-                <a16:creationId xmlns:a16="http://schemas.microsoft.com/office/drawing/2014/main" id="{383E398F-C20F-4E33-8BB2-98260B4C5CF4}"/>
+                <a16:creationId xmlns:a16="http://schemas.microsoft.com/office/drawing/2014/main" id="{3C7CA3E8-9B03-43AD-9571-803A07EE8FD2}"/>
               </a:ext>
             </a:extLst>
           </p:cNvPr>
@@ -6747,7 +6747,7 @@
                 <a:ea typeface="Calibri"/>
                 <a:cs typeface="Calibri"/>
               </a:rPr>
-              <a:t>David Castañeda</a:t>
+              <a:t>David Castillo</a:t>
             </a:r>
           </a:p>
         </p:txBody>
@@ -6757,7 +6757,7 @@
           <p:cNvPr id="9" name="">
             <a:extLst xmlns:a="http://schemas.openxmlformats.org/drawingml/2006/main">
               <a:ext uri="{FF2B5EF4-FFF2-40B4-BE49-F238E27FC236}">
-                <a16:creationId xmlns:a16="http://schemas.microsoft.com/office/drawing/2014/main" id="{C848AEC9-CD0F-4E5F-855B-ACBD16132F4D}"/>
+                <a16:creationId xmlns:a16="http://schemas.microsoft.com/office/drawing/2014/main" id="{6D6DFAA2-E068-46B9-9CA5-5D57BDA7838B}"/>
               </a:ext>
             </a:extLst>
           </p:cNvPr>
@@ -6846,7 +6846,7 @@
     </p:spTree>
     <p:extLst>
       <p:ext uri="{BB962C8B-B14F-4D97-AF65-F5344CB8AC3E}">
-        <p14:creationId xmlns:p14="http://schemas.microsoft.com/office/powerpoint/2010/main" val="1156823226"/>
+        <p14:creationId xmlns:p14="http://schemas.microsoft.com/office/powerpoint/2010/main" val="989938733"/>
       </p:ext>
     </p:extLst>
   </p:cSld>
@@ -6877,7 +6877,7 @@
           <p:cNvPr id="11" name="">
             <a:extLst xmlns:a="http://schemas.openxmlformats.org/drawingml/2006/main">
               <a:ext uri="{FF2B5EF4-FFF2-40B4-BE49-F238E27FC236}">
-                <a16:creationId xmlns:a16="http://schemas.microsoft.com/office/drawing/2014/main" id="{D44429EB-B7E2-485D-81F5-050B7016FB84}"/>
+                <a16:creationId xmlns:a16="http://schemas.microsoft.com/office/drawing/2014/main" id="{528F6217-BB46-49B2-AC3E-ADC14D61E730}"/>
               </a:ext>
             </a:extLst>
           </p:cNvPr>
@@ -6945,7 +6945,7 @@
           <p:cNvPr id="2" name="">
             <a:extLst xmlns:a="http://schemas.openxmlformats.org/drawingml/2006/main">
               <a:ext uri="{FF2B5EF4-FFF2-40B4-BE49-F238E27FC236}">
-                <a16:creationId xmlns:a16="http://schemas.microsoft.com/office/drawing/2014/main" id="{6C87CE12-6986-414C-864C-5B052DE81DD2}"/>
+                <a16:creationId xmlns:a16="http://schemas.microsoft.com/office/drawing/2014/main" id="{E7E9A59B-FB18-43FA-82C3-50FA805A0C27}"/>
               </a:ext>
             </a:extLst>
           </p:cNvPr>
@@ -6975,7 +6975,7 @@
           <p:cNvPr id="3" name="">
             <a:extLst xmlns:a="http://schemas.openxmlformats.org/drawingml/2006/main">
               <a:ext uri="{FF2B5EF4-FFF2-40B4-BE49-F238E27FC236}">
-                <a16:creationId xmlns:a16="http://schemas.microsoft.com/office/drawing/2014/main" id="{A16010A0-BAB1-44F7-B048-22CF4DECBB2B}"/>
+                <a16:creationId xmlns:a16="http://schemas.microsoft.com/office/drawing/2014/main" id="{B753B997-64A2-4D4D-B2BC-5AB3E2800542}"/>
               </a:ext>
             </a:extLst>
           </p:cNvPr>
@@ -7043,7 +7043,7 @@
           <p:cNvPr id="4" name="">
             <a:extLst xmlns:a="http://schemas.openxmlformats.org/drawingml/2006/main">
               <a:ext uri="{FF2B5EF4-FFF2-40B4-BE49-F238E27FC236}">
-                <a16:creationId xmlns:a16="http://schemas.microsoft.com/office/drawing/2014/main" id="{5726C56B-0059-4BCB-BD54-40636903BACE}"/>
+                <a16:creationId xmlns:a16="http://schemas.microsoft.com/office/drawing/2014/main" id="{FCF77D02-0ECA-45BD-B2BE-22E78AD17459}"/>
               </a:ext>
             </a:extLst>
           </p:cNvPr>
@@ -7111,7 +7111,7 @@
           <p:cNvPr id="5" name="Chart">
             <a:extLst xmlns:a="http://schemas.openxmlformats.org/drawingml/2006/main">
               <a:ext uri="{FF2B5EF4-FFF2-40B4-BE49-F238E27FC236}">
-                <a16:creationId xmlns:a16="http://schemas.microsoft.com/office/drawing/2014/main" id="{1AFBBB34-92F2-420B-896D-8E2EA69F278B}"/>
+                <a16:creationId xmlns:a16="http://schemas.microsoft.com/office/drawing/2014/main" id="{B6FB494F-1621-43A4-B473-8764F02AB17F}"/>
               </a:ext>
             </a:extLst>
           </p:cNvPr>
@@ -7124,7 +7124,7 @@
         </p:xfrm>
         <a:graphic xmlns:a="http://schemas.openxmlformats.org/drawingml/2006/main">
           <a:graphicData uri="http://schemas.openxmlformats.org/drawingml/2006/chart">
-            <c:chart xmlns:r="http://schemas.openxmlformats.org/officeDocument/2006/relationships" xmlns:c="http://schemas.openxmlformats.org/drawingml/2006/chart" r:id="R0866cff1b3044209"/>
+            <c:chart xmlns:r="http://schemas.openxmlformats.org/officeDocument/2006/relationships" xmlns:c="http://schemas.openxmlformats.org/drawingml/2006/chart" r:id="R1b2b66a3cb7b4da6"/>
           </a:graphicData>
         </a:graphic>
       </p:graphicFrame>
@@ -7133,7 +7133,7 @@
           <p:cNvPr id="6" name="">
             <a:extLst xmlns:a="http://schemas.openxmlformats.org/drawingml/2006/main">
               <a:ext uri="{FF2B5EF4-FFF2-40B4-BE49-F238E27FC236}">
-                <a16:creationId xmlns:a16="http://schemas.microsoft.com/office/drawing/2014/main" id="{944618DD-6ED0-4844-9782-FE227347F611}"/>
+                <a16:creationId xmlns:a16="http://schemas.microsoft.com/office/drawing/2014/main" id="{C9DF4B9D-AFE8-4983-9FF4-A9E45267F186}"/>
               </a:ext>
             </a:extLst>
           </p:cNvPr>
@@ -7201,7 +7201,7 @@
           <p:cNvPr id="7" name="">
             <a:extLst xmlns:a="http://schemas.openxmlformats.org/drawingml/2006/main">
               <a:ext uri="{FF2B5EF4-FFF2-40B4-BE49-F238E27FC236}">
-                <a16:creationId xmlns:a16="http://schemas.microsoft.com/office/drawing/2014/main" id="{643954A0-1859-43BE-B7E6-372FFA9A8697}"/>
+                <a16:creationId xmlns:a16="http://schemas.microsoft.com/office/drawing/2014/main" id="{9223D3D8-2DDA-4925-BF48-1CE94659626A}"/>
               </a:ext>
             </a:extLst>
           </p:cNvPr>
@@ -7292,7 +7292,7 @@
           <p:cNvPr id="8" name="">
             <a:extLst xmlns:a="http://schemas.openxmlformats.org/drawingml/2006/main">
               <a:ext uri="{FF2B5EF4-FFF2-40B4-BE49-F238E27FC236}">
-                <a16:creationId xmlns:a16="http://schemas.microsoft.com/office/drawing/2014/main" id="{A3963FD4-6519-49CC-9905-532C4BF2038D}"/>
+                <a16:creationId xmlns:a16="http://schemas.microsoft.com/office/drawing/2014/main" id="{A5AED729-F32B-454F-AA00-5B549FAC2EF7}"/>
               </a:ext>
             </a:extLst>
           </p:cNvPr>
@@ -7406,7 +7406,7 @@
           <p:cNvPr id="9" name="">
             <a:extLst xmlns:a="http://schemas.openxmlformats.org/drawingml/2006/main">
               <a:ext uri="{FF2B5EF4-FFF2-40B4-BE49-F238E27FC236}">
-                <a16:creationId xmlns:a16="http://schemas.microsoft.com/office/drawing/2014/main" id="{5B4B5325-08BB-4FDC-BE9A-49197FCF1981}"/>
+                <a16:creationId xmlns:a16="http://schemas.microsoft.com/office/drawing/2014/main" id="{1B90093A-2ECE-44E0-B72C-1BD2049CD113}"/>
               </a:ext>
             </a:extLst>
           </p:cNvPr>
@@ -7474,7 +7474,7 @@
           <p:cNvPr id="10" name="">
             <a:extLst xmlns:a="http://schemas.openxmlformats.org/drawingml/2006/main">
               <a:ext uri="{FF2B5EF4-FFF2-40B4-BE49-F238E27FC236}">
-                <a16:creationId xmlns:a16="http://schemas.microsoft.com/office/drawing/2014/main" id="{8BEB7B54-65FD-46E3-962D-3D1482A38756}"/>
+                <a16:creationId xmlns:a16="http://schemas.microsoft.com/office/drawing/2014/main" id="{8E5BBACC-EC63-41F2-9E22-4D36E7AEFB8D}"/>
               </a:ext>
             </a:extLst>
           </p:cNvPr>
@@ -7540,7 +7540,7 @@
     </p:spTree>
     <p:extLst>
       <p:ext uri="{BB962C8B-B14F-4D97-AF65-F5344CB8AC3E}">
-        <p14:creationId xmlns:p14="http://schemas.microsoft.com/office/powerpoint/2010/main" val="1676745773"/>
+        <p14:creationId xmlns:p14="http://schemas.microsoft.com/office/powerpoint/2010/main" val="1393249125"/>
       </p:ext>
     </p:extLst>
   </p:cSld>
@@ -7571,7 +7571,7 @@
           <p:cNvPr id="10" name="">
             <a:extLst xmlns:a="http://schemas.openxmlformats.org/drawingml/2006/main">
               <a:ext uri="{FF2B5EF4-FFF2-40B4-BE49-F238E27FC236}">
-                <a16:creationId xmlns:a16="http://schemas.microsoft.com/office/drawing/2014/main" id="{FD36827E-5D08-491C-B1DA-FBCBF65601F3}"/>
+                <a16:creationId xmlns:a16="http://schemas.microsoft.com/office/drawing/2014/main" id="{C5E2262F-9E9C-4D13-A114-B6BCD00C3847}"/>
               </a:ext>
             </a:extLst>
           </p:cNvPr>
@@ -7639,7 +7639,7 @@
           <p:cNvPr id="2" name="">
             <a:extLst xmlns:a="http://schemas.openxmlformats.org/drawingml/2006/main">
               <a:ext uri="{FF2B5EF4-FFF2-40B4-BE49-F238E27FC236}">
-                <a16:creationId xmlns:a16="http://schemas.microsoft.com/office/drawing/2014/main" id="{36B30487-5306-413C-AD4E-97DDE4117845}"/>
+                <a16:creationId xmlns:a16="http://schemas.microsoft.com/office/drawing/2014/main" id="{2ACF0438-9DA1-47B6-9190-3086EF80231F}"/>
               </a:ext>
             </a:extLst>
           </p:cNvPr>
@@ -7669,7 +7669,7 @@
           <p:cNvPr id="3" name="">
             <a:extLst xmlns:a="http://schemas.openxmlformats.org/drawingml/2006/main">
               <a:ext uri="{FF2B5EF4-FFF2-40B4-BE49-F238E27FC236}">
-                <a16:creationId xmlns:a16="http://schemas.microsoft.com/office/drawing/2014/main" id="{ACB5E0EA-D64F-46DC-97FA-EBD00022E5BC}"/>
+                <a16:creationId xmlns:a16="http://schemas.microsoft.com/office/drawing/2014/main" id="{466DB89B-D84B-401D-8EE6-6FEC62D68AF0}"/>
               </a:ext>
             </a:extLst>
           </p:cNvPr>
@@ -7737,7 +7737,7 @@
           <p:cNvPr id="4" name="">
             <a:extLst xmlns:a="http://schemas.openxmlformats.org/drawingml/2006/main">
               <a:ext uri="{FF2B5EF4-FFF2-40B4-BE49-F238E27FC236}">
-                <a16:creationId xmlns:a16="http://schemas.microsoft.com/office/drawing/2014/main" id="{ECFF1478-D3A1-4A51-9ACB-2E03AB4CDD68}"/>
+                <a16:creationId xmlns:a16="http://schemas.microsoft.com/office/drawing/2014/main" id="{52D9EA38-4411-429D-8F59-269E5F0F1F72}"/>
               </a:ext>
             </a:extLst>
           </p:cNvPr>
@@ -7805,7 +7805,7 @@
           <p:cNvPr id="5" name="">
             <a:extLst xmlns:a="http://schemas.openxmlformats.org/drawingml/2006/main">
               <a:ext uri="{FF2B5EF4-FFF2-40B4-BE49-F238E27FC236}">
-                <a16:creationId xmlns:a16="http://schemas.microsoft.com/office/drawing/2014/main" id="{89FF2BA9-F9B4-4BBE-8ECA-C26290BA8DF7}"/>
+                <a16:creationId xmlns:a16="http://schemas.microsoft.com/office/drawing/2014/main" id="{6D8BD4CB-F634-481C-BB85-D23702C387BD}"/>
               </a:ext>
             </a:extLst>
           </p:cNvPr>
@@ -8183,7 +8183,7 @@
           <p:cNvPr id="6" name="">
             <a:extLst xmlns:a="http://schemas.openxmlformats.org/drawingml/2006/main">
               <a:ext uri="{FF2B5EF4-FFF2-40B4-BE49-F238E27FC236}">
-                <a16:creationId xmlns:a16="http://schemas.microsoft.com/office/drawing/2014/main" id="{1398ED40-6DF3-441C-ABED-CC5230C39272}"/>
+                <a16:creationId xmlns:a16="http://schemas.microsoft.com/office/drawing/2014/main" id="{3C2CE719-0676-478E-BBF9-BE9E1CA3BE71}"/>
               </a:ext>
             </a:extLst>
           </p:cNvPr>
@@ -8251,7 +8251,7 @@
           <p:cNvPr id="7" name="">
             <a:extLst xmlns:a="http://schemas.openxmlformats.org/drawingml/2006/main">
               <a:ext uri="{FF2B5EF4-FFF2-40B4-BE49-F238E27FC236}">
-                <a16:creationId xmlns:a16="http://schemas.microsoft.com/office/drawing/2014/main" id="{FC693FAE-E907-4D5C-A1D8-127015987748}"/>
+                <a16:creationId xmlns:a16="http://schemas.microsoft.com/office/drawing/2014/main" id="{F7301409-EF3C-400A-BDD3-7B912C3CA9DC}"/>
               </a:ext>
             </a:extLst>
           </p:cNvPr>
@@ -8365,7 +8365,7 @@
           <p:cNvPr id="8" name="">
             <a:extLst xmlns:a="http://schemas.openxmlformats.org/drawingml/2006/main">
               <a:ext uri="{FF2B5EF4-FFF2-40B4-BE49-F238E27FC236}">
-                <a16:creationId xmlns:a16="http://schemas.microsoft.com/office/drawing/2014/main" id="{1C3533FC-43C9-46BC-9A27-E8F30AE822FB}"/>
+                <a16:creationId xmlns:a16="http://schemas.microsoft.com/office/drawing/2014/main" id="{DB99B2DB-2F1B-47C7-827E-660CA5EA543A}"/>
               </a:ext>
             </a:extLst>
           </p:cNvPr>
@@ -8502,7 +8502,7 @@
           <p:cNvPr id="9" name="">
             <a:extLst xmlns:a="http://schemas.openxmlformats.org/drawingml/2006/main">
               <a:ext uri="{FF2B5EF4-FFF2-40B4-BE49-F238E27FC236}">
-                <a16:creationId xmlns:a16="http://schemas.microsoft.com/office/drawing/2014/main" id="{ADF56245-3B0A-46BF-9057-E79BD1979A71}"/>
+                <a16:creationId xmlns:a16="http://schemas.microsoft.com/office/drawing/2014/main" id="{4A804D70-56DB-44F0-AB15-AE2BA794C4B4}"/>
               </a:ext>
             </a:extLst>
           </p:cNvPr>
@@ -8568,7 +8568,7 @@
     </p:spTree>
     <p:extLst>
       <p:ext uri="{BB962C8B-B14F-4D97-AF65-F5344CB8AC3E}">
-        <p14:creationId xmlns:p14="http://schemas.microsoft.com/office/powerpoint/2010/main" val="1903409478"/>
+        <p14:creationId xmlns:p14="http://schemas.microsoft.com/office/powerpoint/2010/main" val="1542768453"/>
       </p:ext>
     </p:extLst>
   </p:cSld>
@@ -8599,7 +8599,7 @@
           <p:cNvPr id="7" name="">
             <a:extLst xmlns:a="http://schemas.openxmlformats.org/drawingml/2006/main">
               <a:ext uri="{FF2B5EF4-FFF2-40B4-BE49-F238E27FC236}">
-                <a16:creationId xmlns:a16="http://schemas.microsoft.com/office/drawing/2014/main" id="{8CE2DB4B-69FE-468F-B654-D77F4667D2CD}"/>
+                <a16:creationId xmlns:a16="http://schemas.microsoft.com/office/drawing/2014/main" id="{FDB46405-1B81-4BE2-97F2-7258868E38B7}"/>
               </a:ext>
             </a:extLst>
           </p:cNvPr>
@@ -8667,7 +8667,7 @@
           <p:cNvPr id="2" name="">
             <a:extLst xmlns:a="http://schemas.openxmlformats.org/drawingml/2006/main">
               <a:ext uri="{FF2B5EF4-FFF2-40B4-BE49-F238E27FC236}">
-                <a16:creationId xmlns:a16="http://schemas.microsoft.com/office/drawing/2014/main" id="{8D9ECDEE-6A35-4272-9578-A882EF6FC96F}"/>
+                <a16:creationId xmlns:a16="http://schemas.microsoft.com/office/drawing/2014/main" id="{84037C87-DCDF-4180-BDEC-9F19854D9257}"/>
               </a:ext>
             </a:extLst>
           </p:cNvPr>
@@ -8697,7 +8697,7 @@
           <p:cNvPr id="3" name="">
             <a:extLst xmlns:a="http://schemas.openxmlformats.org/drawingml/2006/main">
               <a:ext uri="{FF2B5EF4-FFF2-40B4-BE49-F238E27FC236}">
-                <a16:creationId xmlns:a16="http://schemas.microsoft.com/office/drawing/2014/main" id="{0EE0AF90-B143-4A70-9EFD-1B45355C1DFC}"/>
+                <a16:creationId xmlns:a16="http://schemas.microsoft.com/office/drawing/2014/main" id="{F7621639-0616-4174-B0DB-24C7C6322B6F}"/>
               </a:ext>
             </a:extLst>
           </p:cNvPr>
@@ -8765,7 +8765,7 @@
           <p:cNvPr id="4" name="">
             <a:extLst xmlns:a="http://schemas.openxmlformats.org/drawingml/2006/main">
               <a:ext uri="{FF2B5EF4-FFF2-40B4-BE49-F238E27FC236}">
-                <a16:creationId xmlns:a16="http://schemas.microsoft.com/office/drawing/2014/main" id="{0E02718F-4212-4263-89D3-B6A40289FBBA}"/>
+                <a16:creationId xmlns:a16="http://schemas.microsoft.com/office/drawing/2014/main" id="{BFC39D02-7928-469E-BF60-B3C4D23E4BFC}"/>
               </a:ext>
             </a:extLst>
           </p:cNvPr>
@@ -8856,7 +8856,7 @@
           <p:cNvPr id="5" name="">
             <a:extLst xmlns:a="http://schemas.openxmlformats.org/drawingml/2006/main">
               <a:ext uri="{FF2B5EF4-FFF2-40B4-BE49-F238E27FC236}">
-                <a16:creationId xmlns:a16="http://schemas.microsoft.com/office/drawing/2014/main" id="{6FBFF7B3-F540-4EF5-AD6E-3F49C32D86EA}"/>
+                <a16:creationId xmlns:a16="http://schemas.microsoft.com/office/drawing/2014/main" id="{B9DEBE90-38F0-4D0F-9E3E-1686319082C1}"/>
               </a:ext>
             </a:extLst>
           </p:cNvPr>
@@ -9134,7 +9134,7 @@
           <p:cNvPr id="6" name="">
             <a:extLst xmlns:a="http://schemas.openxmlformats.org/drawingml/2006/main">
               <a:ext uri="{FF2B5EF4-FFF2-40B4-BE49-F238E27FC236}">
-                <a16:creationId xmlns:a16="http://schemas.microsoft.com/office/drawing/2014/main" id="{F732E3FA-FBFE-4C73-A769-4F60F3245B16}"/>
+                <a16:creationId xmlns:a16="http://schemas.microsoft.com/office/drawing/2014/main" id="{35066A40-0457-49ED-95E2-5074DACDCA94}"/>
               </a:ext>
             </a:extLst>
           </p:cNvPr>
@@ -9200,7 +9200,7 @@
     </p:spTree>
     <p:extLst>
       <p:ext uri="{BB962C8B-B14F-4D97-AF65-F5344CB8AC3E}">
-        <p14:creationId xmlns:p14="http://schemas.microsoft.com/office/powerpoint/2010/main" val="1996516298"/>
+        <p14:creationId xmlns:p14="http://schemas.microsoft.com/office/powerpoint/2010/main" val="1201765790"/>
       </p:ext>
     </p:extLst>
   </p:cSld>
@@ -9231,7 +9231,7 @@
           <p:cNvPr id="8" name="">
             <a:extLst xmlns:a="http://schemas.openxmlformats.org/drawingml/2006/main">
               <a:ext uri="{FF2B5EF4-FFF2-40B4-BE49-F238E27FC236}">
-                <a16:creationId xmlns:a16="http://schemas.microsoft.com/office/drawing/2014/main" id="{488FDFCB-3412-428E-80B8-7C756BB51F06}"/>
+                <a16:creationId xmlns:a16="http://schemas.microsoft.com/office/drawing/2014/main" id="{97C50530-C3EB-4CF4-AEE5-914886B7FD85}"/>
               </a:ext>
             </a:extLst>
           </p:cNvPr>
@@ -9299,7 +9299,7 @@
           <p:cNvPr id="2" name="">
             <a:extLst xmlns:a="http://schemas.openxmlformats.org/drawingml/2006/main">
               <a:ext uri="{FF2B5EF4-FFF2-40B4-BE49-F238E27FC236}">
-                <a16:creationId xmlns:a16="http://schemas.microsoft.com/office/drawing/2014/main" id="{E909A7ED-0188-4B7A-9F27-323079345D96}"/>
+                <a16:creationId xmlns:a16="http://schemas.microsoft.com/office/drawing/2014/main" id="{DB8B9F08-8675-4D27-A573-49A7D7D228A4}"/>
               </a:ext>
             </a:extLst>
           </p:cNvPr>
@@ -9329,7 +9329,7 @@
           <p:cNvPr id="3" name="">
             <a:extLst xmlns:a="http://schemas.openxmlformats.org/drawingml/2006/main">
               <a:ext uri="{FF2B5EF4-FFF2-40B4-BE49-F238E27FC236}">
-                <a16:creationId xmlns:a16="http://schemas.microsoft.com/office/drawing/2014/main" id="{7D258BD3-3375-48D1-83C7-74E1B6459A0E}"/>
+                <a16:creationId xmlns:a16="http://schemas.microsoft.com/office/drawing/2014/main" id="{4EA24188-0687-4F42-B77A-C0D60277C876}"/>
               </a:ext>
             </a:extLst>
           </p:cNvPr>
@@ -9397,7 +9397,7 @@
           <p:cNvPr id="4" name="">
             <a:extLst xmlns:a="http://schemas.openxmlformats.org/drawingml/2006/main">
               <a:ext uri="{FF2B5EF4-FFF2-40B4-BE49-F238E27FC236}">
-                <a16:creationId xmlns:a16="http://schemas.microsoft.com/office/drawing/2014/main" id="{FAB91F7E-B3F7-41D1-9B27-D6F77AA8776A}"/>
+                <a16:creationId xmlns:a16="http://schemas.microsoft.com/office/drawing/2014/main" id="{C3B29676-FFD7-46A0-BA4F-11D7979C4585}"/>
               </a:ext>
             </a:extLst>
           </p:cNvPr>
@@ -9465,7 +9465,7 @@
           <p:cNvPr id="5" name="">
             <a:extLst xmlns:a="http://schemas.openxmlformats.org/drawingml/2006/main">
               <a:ext uri="{FF2B5EF4-FFF2-40B4-BE49-F238E27FC236}">
-                <a16:creationId xmlns:a16="http://schemas.microsoft.com/office/drawing/2014/main" id="{9B51BF3A-2C2C-47E9-B722-89AB417C9C31}"/>
+                <a16:creationId xmlns:a16="http://schemas.microsoft.com/office/drawing/2014/main" id="{1E1DAF74-E88C-485B-AA77-4FA9EC8BE77B}"/>
               </a:ext>
             </a:extLst>
           </p:cNvPr>
@@ -9533,7 +9533,7 @@
           <p:cNvPr id="6" name="">
             <a:extLst xmlns:a="http://schemas.openxmlformats.org/drawingml/2006/main">
               <a:ext uri="{FF2B5EF4-FFF2-40B4-BE49-F238E27FC236}">
-                <a16:creationId xmlns:a16="http://schemas.microsoft.com/office/drawing/2014/main" id="{191B13AD-A997-44FB-8AA2-F8D470E3DDF6}"/>
+                <a16:creationId xmlns:a16="http://schemas.microsoft.com/office/drawing/2014/main" id="{E9752840-885C-4593-A2E6-F1F17F6E2CB7}"/>
               </a:ext>
             </a:extLst>
           </p:cNvPr>
@@ -9761,7 +9761,7 @@
           <p:cNvPr id="7" name="">
             <a:extLst xmlns:a="http://schemas.openxmlformats.org/drawingml/2006/main">
               <a:ext uri="{FF2B5EF4-FFF2-40B4-BE49-F238E27FC236}">
-                <a16:creationId xmlns:a16="http://schemas.microsoft.com/office/drawing/2014/main" id="{FBAA4B67-4CA5-4DDE-AABD-D1AC8EE1541B}"/>
+                <a16:creationId xmlns:a16="http://schemas.microsoft.com/office/drawing/2014/main" id="{5EB0E0EA-EF3F-420A-B6FD-9FEC40B0181B}"/>
               </a:ext>
             </a:extLst>
           </p:cNvPr>
@@ -9827,7 +9827,7 @@
     </p:spTree>
     <p:extLst>
       <p:ext uri="{BB962C8B-B14F-4D97-AF65-F5344CB8AC3E}">
-        <p14:creationId xmlns:p14="http://schemas.microsoft.com/office/powerpoint/2010/main" val="1885508341"/>
+        <p14:creationId xmlns:p14="http://schemas.microsoft.com/office/powerpoint/2010/main" val="1682699398"/>
       </p:ext>
     </p:extLst>
   </p:cSld>
@@ -9858,7 +9858,7 @@
           <p:cNvPr id="9" name="">
             <a:extLst xmlns:a="http://schemas.openxmlformats.org/drawingml/2006/main">
               <a:ext uri="{FF2B5EF4-FFF2-40B4-BE49-F238E27FC236}">
-                <a16:creationId xmlns:a16="http://schemas.microsoft.com/office/drawing/2014/main" id="{5877682E-18CD-40EA-97A9-27E6B590D632}"/>
+                <a16:creationId xmlns:a16="http://schemas.microsoft.com/office/drawing/2014/main" id="{E9BE8CE0-5871-441D-B23B-A6E8A46B1989}"/>
               </a:ext>
             </a:extLst>
           </p:cNvPr>
@@ -9926,7 +9926,7 @@
           <p:cNvPr id="2" name="">
             <a:extLst xmlns:a="http://schemas.openxmlformats.org/drawingml/2006/main">
               <a:ext uri="{FF2B5EF4-FFF2-40B4-BE49-F238E27FC236}">
-                <a16:creationId xmlns:a16="http://schemas.microsoft.com/office/drawing/2014/main" id="{7DA99E3B-3184-4B70-9859-B435DE5F2A9D}"/>
+                <a16:creationId xmlns:a16="http://schemas.microsoft.com/office/drawing/2014/main" id="{6586B70A-58CE-43AB-AC63-B8DE8944E68E}"/>
               </a:ext>
             </a:extLst>
           </p:cNvPr>
@@ -9956,7 +9956,7 @@
           <p:cNvPr id="3" name="">
             <a:extLst xmlns:a="http://schemas.openxmlformats.org/drawingml/2006/main">
               <a:ext uri="{FF2B5EF4-FFF2-40B4-BE49-F238E27FC236}">
-                <a16:creationId xmlns:a16="http://schemas.microsoft.com/office/drawing/2014/main" id="{B1A64037-143B-45A8-995D-5134084174FF}"/>
+                <a16:creationId xmlns:a16="http://schemas.microsoft.com/office/drawing/2014/main" id="{D8360D09-6F06-40BD-8EB7-27FAEA9C8EC3}"/>
               </a:ext>
             </a:extLst>
           </p:cNvPr>
@@ -10024,7 +10024,7 @@
           <p:cNvPr id="4" name="">
             <a:extLst xmlns:a="http://schemas.openxmlformats.org/drawingml/2006/main">
               <a:ext uri="{FF2B5EF4-FFF2-40B4-BE49-F238E27FC236}">
-                <a16:creationId xmlns:a16="http://schemas.microsoft.com/office/drawing/2014/main" id="{8417DF4E-9D2C-401E-A7CF-9893E04AB38F}"/>
+                <a16:creationId xmlns:a16="http://schemas.microsoft.com/office/drawing/2014/main" id="{B52E139A-69E9-4ABF-A595-00335449607B}"/>
               </a:ext>
             </a:extLst>
           </p:cNvPr>
@@ -10092,7 +10092,7 @@
           <p:cNvPr id="5" name="">
             <a:extLst xmlns:a="http://schemas.openxmlformats.org/drawingml/2006/main">
               <a:ext uri="{FF2B5EF4-FFF2-40B4-BE49-F238E27FC236}">
-                <a16:creationId xmlns:a16="http://schemas.microsoft.com/office/drawing/2014/main" id="{6433FD1A-0823-49F3-8961-42A48EB3163E}"/>
+                <a16:creationId xmlns:a16="http://schemas.microsoft.com/office/drawing/2014/main" id="{1D35972B-47C5-4F80-9F87-C17841808F3A}"/>
               </a:ext>
             </a:extLst>
           </p:cNvPr>
@@ -10160,7 +10160,7 @@
           <p:cNvPr id="6" name="">
             <a:extLst xmlns:a="http://schemas.openxmlformats.org/drawingml/2006/main">
               <a:ext uri="{FF2B5EF4-FFF2-40B4-BE49-F238E27FC236}">
-                <a16:creationId xmlns:a16="http://schemas.microsoft.com/office/drawing/2014/main" id="{9D439353-1DEE-414F-8DBF-5821A27DEEA1}"/>
+                <a16:creationId xmlns:a16="http://schemas.microsoft.com/office/drawing/2014/main" id="{FFCBF2C8-20AF-43C7-8831-4542814E1ED1}"/>
               </a:ext>
             </a:extLst>
           </p:cNvPr>
@@ -10251,7 +10251,7 @@
           <p:cNvPr id="7" name="">
             <a:extLst xmlns:a="http://schemas.openxmlformats.org/drawingml/2006/main">
               <a:ext uri="{FF2B5EF4-FFF2-40B4-BE49-F238E27FC236}">
-                <a16:creationId xmlns:a16="http://schemas.microsoft.com/office/drawing/2014/main" id="{5B54724E-95F7-4610-A715-4070440C08D8}"/>
+                <a16:creationId xmlns:a16="http://schemas.microsoft.com/office/drawing/2014/main" id="{0962CA88-A5C3-4010-BD0F-75E3CA8E235A}"/>
               </a:ext>
             </a:extLst>
           </p:cNvPr>
@@ -10505,7 +10505,7 @@
           <p:cNvPr id="8" name="">
             <a:extLst xmlns:a="http://schemas.openxmlformats.org/drawingml/2006/main">
               <a:ext uri="{FF2B5EF4-FFF2-40B4-BE49-F238E27FC236}">
-                <a16:creationId xmlns:a16="http://schemas.microsoft.com/office/drawing/2014/main" id="{1931AE6A-F86C-4586-A771-DD55CE42B7FF}"/>
+                <a16:creationId xmlns:a16="http://schemas.microsoft.com/office/drawing/2014/main" id="{14D533C9-4E61-4F3D-B24B-47F1A41A2BD7}"/>
               </a:ext>
             </a:extLst>
           </p:cNvPr>
@@ -10571,7 +10571,7 @@
     </p:spTree>
     <p:extLst>
       <p:ext uri="{BB962C8B-B14F-4D97-AF65-F5344CB8AC3E}">
-        <p14:creationId xmlns:p14="http://schemas.microsoft.com/office/powerpoint/2010/main" val="1004792606"/>
+        <p14:creationId xmlns:p14="http://schemas.microsoft.com/office/powerpoint/2010/main" val="1502850572"/>
       </p:ext>
     </p:extLst>
   </p:cSld>
@@ -10602,7 +10602,7 @@
           <p:cNvPr id="7" name="">
             <a:extLst xmlns:a="http://schemas.openxmlformats.org/drawingml/2006/main">
               <a:ext uri="{FF2B5EF4-FFF2-40B4-BE49-F238E27FC236}">
-                <a16:creationId xmlns:a16="http://schemas.microsoft.com/office/drawing/2014/main" id="{71082EB8-5C4C-4468-8C20-81552FDFD266}"/>
+                <a16:creationId xmlns:a16="http://schemas.microsoft.com/office/drawing/2014/main" id="{E4B275E3-4615-437E-8165-A6394EE3E259}"/>
               </a:ext>
             </a:extLst>
           </p:cNvPr>
@@ -10670,7 +10670,7 @@
           <p:cNvPr id="2" name="">
             <a:extLst xmlns:a="http://schemas.openxmlformats.org/drawingml/2006/main">
               <a:ext uri="{FF2B5EF4-FFF2-40B4-BE49-F238E27FC236}">
-                <a16:creationId xmlns:a16="http://schemas.microsoft.com/office/drawing/2014/main" id="{46E680C8-8E0E-4F95-8C98-E57ED90F3A74}"/>
+                <a16:creationId xmlns:a16="http://schemas.microsoft.com/office/drawing/2014/main" id="{E5D65316-8D7A-456D-86B5-5A5F4F51EFB4}"/>
               </a:ext>
             </a:extLst>
           </p:cNvPr>
@@ -10700,7 +10700,7 @@
           <p:cNvPr id="3" name="">
             <a:extLst xmlns:a="http://schemas.openxmlformats.org/drawingml/2006/main">
               <a:ext uri="{FF2B5EF4-FFF2-40B4-BE49-F238E27FC236}">
-                <a16:creationId xmlns:a16="http://schemas.microsoft.com/office/drawing/2014/main" id="{EA09D9CE-B01E-40A6-833F-23475EEEAAF3}"/>
+                <a16:creationId xmlns:a16="http://schemas.microsoft.com/office/drawing/2014/main" id="{4F7CFB55-858C-423C-815B-4E9A39796E3C}"/>
               </a:ext>
             </a:extLst>
           </p:cNvPr>
@@ -10768,7 +10768,7 @@
           <p:cNvPr id="4" name="">
             <a:extLst xmlns:a="http://schemas.openxmlformats.org/drawingml/2006/main">
               <a:ext uri="{FF2B5EF4-FFF2-40B4-BE49-F238E27FC236}">
-                <a16:creationId xmlns:a16="http://schemas.microsoft.com/office/drawing/2014/main" id="{EC10B926-37C1-4A5F-A8F2-54F2FF56A5A0}"/>
+                <a16:creationId xmlns:a16="http://schemas.microsoft.com/office/drawing/2014/main" id="{64D58BBA-3556-4E99-8341-073B42B75862}"/>
               </a:ext>
             </a:extLst>
           </p:cNvPr>
@@ -11323,7 +11323,7 @@
           <p:cNvPr id="5" name="">
             <a:extLst xmlns:a="http://schemas.openxmlformats.org/drawingml/2006/main">
               <a:ext uri="{FF2B5EF4-FFF2-40B4-BE49-F238E27FC236}">
-                <a16:creationId xmlns:a16="http://schemas.microsoft.com/office/drawing/2014/main" id="{4B5C5CE2-B010-4811-A025-AEC2D331CCE4}"/>
+                <a16:creationId xmlns:a16="http://schemas.microsoft.com/office/drawing/2014/main" id="{F622A721-C9CB-46F3-87BF-6D14E2FF521D}"/>
               </a:ext>
             </a:extLst>
           </p:cNvPr>
@@ -11391,7 +11391,7 @@
           <p:cNvPr id="6" name="">
             <a:extLst xmlns:a="http://schemas.openxmlformats.org/drawingml/2006/main">
               <a:ext uri="{FF2B5EF4-FFF2-40B4-BE49-F238E27FC236}">
-                <a16:creationId xmlns:a16="http://schemas.microsoft.com/office/drawing/2014/main" id="{BA94DFA1-1595-4BE8-A193-3C768A7CBF95}"/>
+                <a16:creationId xmlns:a16="http://schemas.microsoft.com/office/drawing/2014/main" id="{A7000AD1-4A10-4CA6-A0A4-3F4B96C37A3B}"/>
               </a:ext>
             </a:extLst>
           </p:cNvPr>
@@ -11480,7 +11480,7 @@
     </p:spTree>
     <p:extLst>
       <p:ext uri="{BB962C8B-B14F-4D97-AF65-F5344CB8AC3E}">
-        <p14:creationId xmlns:p14="http://schemas.microsoft.com/office/powerpoint/2010/main" val="1359516468"/>
+        <p14:creationId xmlns:p14="http://schemas.microsoft.com/office/powerpoint/2010/main" val="1009542659"/>
       </p:ext>
     </p:extLst>
   </p:cSld>
@@ -11511,7 +11511,7 @@
           <p:cNvPr id="10" name="">
             <a:extLst xmlns:a="http://schemas.openxmlformats.org/drawingml/2006/main">
               <a:ext uri="{FF2B5EF4-FFF2-40B4-BE49-F238E27FC236}">
-                <a16:creationId xmlns:a16="http://schemas.microsoft.com/office/drawing/2014/main" id="{F23A5B45-F840-443F-BA7E-A8E75D50516E}"/>
+                <a16:creationId xmlns:a16="http://schemas.microsoft.com/office/drawing/2014/main" id="{FB3FAE90-CCB2-4CC3-99E1-31D9CCF47630}"/>
               </a:ext>
             </a:extLst>
           </p:cNvPr>
@@ -11579,7 +11579,7 @@
           <p:cNvPr id="2" name="">
             <a:extLst xmlns:a="http://schemas.openxmlformats.org/drawingml/2006/main">
               <a:ext uri="{FF2B5EF4-FFF2-40B4-BE49-F238E27FC236}">
-                <a16:creationId xmlns:a16="http://schemas.microsoft.com/office/drawing/2014/main" id="{9C6CE6A5-4F0A-43E0-97B6-B615534F912F}"/>
+                <a16:creationId xmlns:a16="http://schemas.microsoft.com/office/drawing/2014/main" id="{D35EB820-0974-4B6F-9CFC-A2E7E1A2615C}"/>
               </a:ext>
             </a:extLst>
           </p:cNvPr>
@@ -11609,7 +11609,7 @@
           <p:cNvPr id="3" name="">
             <a:extLst xmlns:a="http://schemas.openxmlformats.org/drawingml/2006/main">
               <a:ext uri="{FF2B5EF4-FFF2-40B4-BE49-F238E27FC236}">
-                <a16:creationId xmlns:a16="http://schemas.microsoft.com/office/drawing/2014/main" id="{3F822493-A841-4179-BFD1-570AE3414D4B}"/>
+                <a16:creationId xmlns:a16="http://schemas.microsoft.com/office/drawing/2014/main" id="{41B2B74C-6DF2-4BAD-8DC9-E29E4DBB0341}"/>
               </a:ext>
             </a:extLst>
           </p:cNvPr>
@@ -11677,7 +11677,7 @@
           <p:cNvPr id="4" name="">
             <a:extLst xmlns:a="http://schemas.openxmlformats.org/drawingml/2006/main">
               <a:ext uri="{FF2B5EF4-FFF2-40B4-BE49-F238E27FC236}">
-                <a16:creationId xmlns:a16="http://schemas.microsoft.com/office/drawing/2014/main" id="{C071F7F6-86C2-4D0B-858B-6BB0316D525F}"/>
+                <a16:creationId xmlns:a16="http://schemas.microsoft.com/office/drawing/2014/main" id="{503225C4-DBF3-4D85-AE0E-1EA131D735A7}"/>
               </a:ext>
             </a:extLst>
           </p:cNvPr>
@@ -11745,7 +11745,7 @@
           <p:cNvPr id="5" name="">
             <a:extLst xmlns:a="http://schemas.openxmlformats.org/drawingml/2006/main">
               <a:ext uri="{FF2B5EF4-FFF2-40B4-BE49-F238E27FC236}">
-                <a16:creationId xmlns:a16="http://schemas.microsoft.com/office/drawing/2014/main" id="{EA4C7635-57C0-4A46-B64E-1C9DC71420C7}"/>
+                <a16:creationId xmlns:a16="http://schemas.microsoft.com/office/drawing/2014/main" id="{6936361A-8F30-4AA1-ADB7-3D1289685FA5}"/>
               </a:ext>
             </a:extLst>
           </p:cNvPr>
@@ -11813,7 +11813,7 @@
           <p:cNvPr id="6" name="Chart">
             <a:extLst xmlns:a="http://schemas.openxmlformats.org/drawingml/2006/main">
               <a:ext uri="{FF2B5EF4-FFF2-40B4-BE49-F238E27FC236}">
-                <a16:creationId xmlns:a16="http://schemas.microsoft.com/office/drawing/2014/main" id="{DB36488A-9B09-43FB-BEFF-38B7EF0D2048}"/>
+                <a16:creationId xmlns:a16="http://schemas.microsoft.com/office/drawing/2014/main" id="{630DE53C-88E9-444C-960E-AF2FD796286E}"/>
               </a:ext>
             </a:extLst>
           </p:cNvPr>
@@ -11826,7 +11826,7 @@
         </p:xfrm>
         <a:graphic xmlns:a="http://schemas.openxmlformats.org/drawingml/2006/main">
           <a:graphicData uri="http://schemas.openxmlformats.org/drawingml/2006/chart">
-            <c:chart xmlns:r="http://schemas.openxmlformats.org/officeDocument/2006/relationships" xmlns:c="http://schemas.openxmlformats.org/drawingml/2006/chart" r:id="R4e45f85bbb724e22"/>
+            <c:chart xmlns:r="http://schemas.openxmlformats.org/officeDocument/2006/relationships" xmlns:c="http://schemas.openxmlformats.org/drawingml/2006/chart" r:id="R3998a93a8dec472b"/>
           </a:graphicData>
         </a:graphic>
       </p:graphicFrame>
@@ -11835,7 +11835,7 @@
           <p:cNvPr id="7" name="">
             <a:extLst xmlns:a="http://schemas.openxmlformats.org/drawingml/2006/main">
               <a:ext uri="{FF2B5EF4-FFF2-40B4-BE49-F238E27FC236}">
-                <a16:creationId xmlns:a16="http://schemas.microsoft.com/office/drawing/2014/main" id="{5652F6DD-FB29-4C18-96FB-AD1686C74482}"/>
+                <a16:creationId xmlns:a16="http://schemas.microsoft.com/office/drawing/2014/main" id="{261B8B37-E537-4C16-9ABF-DABCCF9C9A93}"/>
               </a:ext>
             </a:extLst>
           </p:cNvPr>
@@ -12160,7 +12160,7 @@
           <p:cNvPr id="8" name="">
             <a:extLst xmlns:a="http://schemas.openxmlformats.org/drawingml/2006/main">
               <a:ext uri="{FF2B5EF4-FFF2-40B4-BE49-F238E27FC236}">
-                <a16:creationId xmlns:a16="http://schemas.microsoft.com/office/drawing/2014/main" id="{03625DC6-69BD-463A-8B39-8C884F0C47B2}"/>
+                <a16:creationId xmlns:a16="http://schemas.microsoft.com/office/drawing/2014/main" id="{3C255ED2-2818-464F-B13C-AD0FBCBAC1BC}"/>
               </a:ext>
             </a:extLst>
           </p:cNvPr>
@@ -12274,7 +12274,7 @@
           <p:cNvPr id="9" name="">
             <a:extLst xmlns:a="http://schemas.openxmlformats.org/drawingml/2006/main">
               <a:ext uri="{FF2B5EF4-FFF2-40B4-BE49-F238E27FC236}">
-                <a16:creationId xmlns:a16="http://schemas.microsoft.com/office/drawing/2014/main" id="{28E4D57A-E43A-4A1D-AD04-977B6536022F}"/>
+                <a16:creationId xmlns:a16="http://schemas.microsoft.com/office/drawing/2014/main" id="{EAA5817E-E0BE-496D-8846-09901F0CB871}"/>
               </a:ext>
             </a:extLst>
           </p:cNvPr>
@@ -12340,7 +12340,7 @@
     </p:spTree>
     <p:extLst>
       <p:ext uri="{BB962C8B-B14F-4D97-AF65-F5344CB8AC3E}">
-        <p14:creationId xmlns:p14="http://schemas.microsoft.com/office/powerpoint/2010/main" val="884316604"/>
+        <p14:creationId xmlns:p14="http://schemas.microsoft.com/office/powerpoint/2010/main" val="179417822"/>
       </p:ext>
     </p:extLst>
   </p:cSld>
@@ -12371,7 +12371,7 @@
           <p:cNvPr id="12" name="">
             <a:extLst xmlns:a="http://schemas.openxmlformats.org/drawingml/2006/main">
               <a:ext uri="{FF2B5EF4-FFF2-40B4-BE49-F238E27FC236}">
-                <a16:creationId xmlns:a16="http://schemas.microsoft.com/office/drawing/2014/main" id="{0E0A0827-DF99-4989-A8E6-73C70362A54C}"/>
+                <a16:creationId xmlns:a16="http://schemas.microsoft.com/office/drawing/2014/main" id="{138338C8-6F9B-47DF-8F23-E4E94F916E00}"/>
               </a:ext>
             </a:extLst>
           </p:cNvPr>
@@ -12439,7 +12439,7 @@
           <p:cNvPr id="2" name="">
             <a:extLst xmlns:a="http://schemas.openxmlformats.org/drawingml/2006/main">
               <a:ext uri="{FF2B5EF4-FFF2-40B4-BE49-F238E27FC236}">
-                <a16:creationId xmlns:a16="http://schemas.microsoft.com/office/drawing/2014/main" id="{35446BA1-DC69-49F2-9900-A023DB4655C6}"/>
+                <a16:creationId xmlns:a16="http://schemas.microsoft.com/office/drawing/2014/main" id="{154C0E21-4A02-4247-849E-D57752538F3B}"/>
               </a:ext>
             </a:extLst>
           </p:cNvPr>
@@ -12469,7 +12469,7 @@
           <p:cNvPr id="3" name="">
             <a:extLst xmlns:a="http://schemas.openxmlformats.org/drawingml/2006/main">
               <a:ext uri="{FF2B5EF4-FFF2-40B4-BE49-F238E27FC236}">
-                <a16:creationId xmlns:a16="http://schemas.microsoft.com/office/drawing/2014/main" id="{5D598877-28DF-48EB-9811-1A66F2BE2879}"/>
+                <a16:creationId xmlns:a16="http://schemas.microsoft.com/office/drawing/2014/main" id="{A2C9234C-D5BD-41C9-912C-0977A8DB79A7}"/>
               </a:ext>
             </a:extLst>
           </p:cNvPr>
@@ -12537,7 +12537,7 @@
           <p:cNvPr id="4" name="">
             <a:extLst xmlns:a="http://schemas.openxmlformats.org/drawingml/2006/main">
               <a:ext uri="{FF2B5EF4-FFF2-40B4-BE49-F238E27FC236}">
-                <a16:creationId xmlns:a16="http://schemas.microsoft.com/office/drawing/2014/main" id="{9E625846-5059-4F5B-8474-809004642E03}"/>
+                <a16:creationId xmlns:a16="http://schemas.microsoft.com/office/drawing/2014/main" id="{3D5B0C8C-CCD0-47B8-843E-BFDA8A1D30EF}"/>
               </a:ext>
             </a:extLst>
           </p:cNvPr>
@@ -12605,7 +12605,7 @@
           <p:cNvPr id="5" name="Chart">
             <a:extLst xmlns:a="http://schemas.openxmlformats.org/drawingml/2006/main">
               <a:ext uri="{FF2B5EF4-FFF2-40B4-BE49-F238E27FC236}">
-                <a16:creationId xmlns:a16="http://schemas.microsoft.com/office/drawing/2014/main" id="{4FB76E10-730F-4B23-A605-8E1E80A2B939}"/>
+                <a16:creationId xmlns:a16="http://schemas.microsoft.com/office/drawing/2014/main" id="{253E750C-C6A8-40EC-BF5D-E5C7B05C51DA}"/>
               </a:ext>
             </a:extLst>
           </p:cNvPr>
@@ -12618,7 +12618,7 @@
         </p:xfrm>
         <a:graphic xmlns:a="http://schemas.openxmlformats.org/drawingml/2006/main">
           <a:graphicData uri="http://schemas.openxmlformats.org/drawingml/2006/chart">
-            <c:chart xmlns:r="http://schemas.openxmlformats.org/officeDocument/2006/relationships" xmlns:c="http://schemas.openxmlformats.org/drawingml/2006/chart" r:id="R9ef429176dd34c53"/>
+            <c:chart xmlns:r="http://schemas.openxmlformats.org/officeDocument/2006/relationships" xmlns:c="http://schemas.openxmlformats.org/drawingml/2006/chart" r:id="R29272d4fb6824494"/>
           </a:graphicData>
         </a:graphic>
       </p:graphicFrame>
@@ -12627,7 +12627,7 @@
           <p:cNvPr id="6" name="">
             <a:extLst xmlns:a="http://schemas.openxmlformats.org/drawingml/2006/main">
               <a:ext uri="{FF2B5EF4-FFF2-40B4-BE49-F238E27FC236}">
-                <a16:creationId xmlns:a16="http://schemas.microsoft.com/office/drawing/2014/main" id="{CF4A9C1B-F8D1-4B4B-B1E9-F8AF7E8552A8}"/>
+                <a16:creationId xmlns:a16="http://schemas.microsoft.com/office/drawing/2014/main" id="{346CA03B-BBE1-4407-BB7A-289837DC052F}"/>
               </a:ext>
             </a:extLst>
           </p:cNvPr>
@@ -12695,7 +12695,7 @@
           <p:cNvPr id="7" name="">
             <a:extLst xmlns:a="http://schemas.openxmlformats.org/drawingml/2006/main">
               <a:ext uri="{FF2B5EF4-FFF2-40B4-BE49-F238E27FC236}">
-                <a16:creationId xmlns:a16="http://schemas.microsoft.com/office/drawing/2014/main" id="{09C18D4C-6D3D-4DEA-A9A6-F43E34C29846}"/>
+                <a16:creationId xmlns:a16="http://schemas.microsoft.com/office/drawing/2014/main" id="{348FD152-6EEE-4027-A9D0-C7124D00FE7C}"/>
               </a:ext>
             </a:extLst>
           </p:cNvPr>
@@ -12809,7 +12809,7 @@
           <p:cNvPr id="8" name="">
             <a:extLst xmlns:a="http://schemas.openxmlformats.org/drawingml/2006/main">
               <a:ext uri="{FF2B5EF4-FFF2-40B4-BE49-F238E27FC236}">
-                <a16:creationId xmlns:a16="http://schemas.microsoft.com/office/drawing/2014/main" id="{168CAB6F-C693-4205-871D-44B0A4914194}"/>
+                <a16:creationId xmlns:a16="http://schemas.microsoft.com/office/drawing/2014/main" id="{85EC8217-DE5F-4BDA-B81B-B2BBE91F127D}"/>
               </a:ext>
             </a:extLst>
           </p:cNvPr>
@@ -12877,7 +12877,7 @@
           <p:cNvPr id="9" name="">
             <a:extLst xmlns:a="http://schemas.openxmlformats.org/drawingml/2006/main">
               <a:ext uri="{FF2B5EF4-FFF2-40B4-BE49-F238E27FC236}">
-                <a16:creationId xmlns:a16="http://schemas.microsoft.com/office/drawing/2014/main" id="{32E76482-774D-4963-A7BC-7952026FD7BE}"/>
+                <a16:creationId xmlns:a16="http://schemas.microsoft.com/office/drawing/2014/main" id="{A1ECCD07-FA76-44F7-A5FF-06DFC3BA6088}"/>
               </a:ext>
             </a:extLst>
           </p:cNvPr>
@@ -13014,7 +13014,7 @@
           <p:cNvPr id="10" name="">
             <a:extLst xmlns:a="http://schemas.openxmlformats.org/drawingml/2006/main">
               <a:ext uri="{FF2B5EF4-FFF2-40B4-BE49-F238E27FC236}">
-                <a16:creationId xmlns:a16="http://schemas.microsoft.com/office/drawing/2014/main" id="{DB3EC7CA-EA40-4E38-90F9-3766F67FAC67}"/>
+                <a16:creationId xmlns:a16="http://schemas.microsoft.com/office/drawing/2014/main" id="{0528B4F9-595E-46EE-8D1E-C40B71EE5288}"/>
               </a:ext>
             </a:extLst>
           </p:cNvPr>
@@ -13082,7 +13082,7 @@
           <p:cNvPr id="11" name="">
             <a:extLst xmlns:a="http://schemas.openxmlformats.org/drawingml/2006/main">
               <a:ext uri="{FF2B5EF4-FFF2-40B4-BE49-F238E27FC236}">
-                <a16:creationId xmlns:a16="http://schemas.microsoft.com/office/drawing/2014/main" id="{7F14CBA3-ED44-4B2B-9080-11DD9F0E71D2}"/>
+                <a16:creationId xmlns:a16="http://schemas.microsoft.com/office/drawing/2014/main" id="{2824177D-BD8C-4034-99AA-A0A68C5A7A53}"/>
               </a:ext>
             </a:extLst>
           </p:cNvPr>
@@ -13148,7 +13148,7 @@
     </p:spTree>
     <p:extLst>
       <p:ext uri="{BB962C8B-B14F-4D97-AF65-F5344CB8AC3E}">
-        <p14:creationId xmlns:p14="http://schemas.microsoft.com/office/powerpoint/2010/main" val="1649714703"/>
+        <p14:creationId xmlns:p14="http://schemas.microsoft.com/office/powerpoint/2010/main" val="1571321813"/>
       </p:ext>
     </p:extLst>
   </p:cSld>
@@ -13179,7 +13179,7 @@
           <p:cNvPr id="11" name="">
             <a:extLst xmlns:a="http://schemas.openxmlformats.org/drawingml/2006/main">
               <a:ext uri="{FF2B5EF4-FFF2-40B4-BE49-F238E27FC236}">
-                <a16:creationId xmlns:a16="http://schemas.microsoft.com/office/drawing/2014/main" id="{4370B047-43D6-4A6C-B338-4EF26AFFA4E6}"/>
+                <a16:creationId xmlns:a16="http://schemas.microsoft.com/office/drawing/2014/main" id="{3D64FAFB-1A40-422B-BC9B-CA3E16FF3C8E}"/>
               </a:ext>
             </a:extLst>
           </p:cNvPr>
@@ -13247,7 +13247,7 @@
           <p:cNvPr id="2" name="">
             <a:extLst xmlns:a="http://schemas.openxmlformats.org/drawingml/2006/main">
               <a:ext uri="{FF2B5EF4-FFF2-40B4-BE49-F238E27FC236}">
-                <a16:creationId xmlns:a16="http://schemas.microsoft.com/office/drawing/2014/main" id="{F38FE2E0-27A0-46BF-A836-C0056A4E7D40}"/>
+                <a16:creationId xmlns:a16="http://schemas.microsoft.com/office/drawing/2014/main" id="{628828E4-D60D-48F2-9D97-23F7CA0D3B33}"/>
               </a:ext>
             </a:extLst>
           </p:cNvPr>
@@ -13277,7 +13277,7 @@
           <p:cNvPr id="3" name="">
             <a:extLst xmlns:a="http://schemas.openxmlformats.org/drawingml/2006/main">
               <a:ext uri="{FF2B5EF4-FFF2-40B4-BE49-F238E27FC236}">
-                <a16:creationId xmlns:a16="http://schemas.microsoft.com/office/drawing/2014/main" id="{074DCBB5-1CE3-4B4D-B323-8F45712EFE11}"/>
+                <a16:creationId xmlns:a16="http://schemas.microsoft.com/office/drawing/2014/main" id="{41F717A3-3BC5-4F11-8EF6-6F6372DAE4E3}"/>
               </a:ext>
             </a:extLst>
           </p:cNvPr>
@@ -13345,7 +13345,7 @@
           <p:cNvPr id="4" name="">
             <a:extLst xmlns:a="http://schemas.openxmlformats.org/drawingml/2006/main">
               <a:ext uri="{FF2B5EF4-FFF2-40B4-BE49-F238E27FC236}">
-                <a16:creationId xmlns:a16="http://schemas.microsoft.com/office/drawing/2014/main" id="{5922B559-B1A1-4BFB-AF53-D9B0A1FD7007}"/>
+                <a16:creationId xmlns:a16="http://schemas.microsoft.com/office/drawing/2014/main" id="{1CE723C9-40D0-4F99-8658-8D4E7D7C0382}"/>
               </a:ext>
             </a:extLst>
           </p:cNvPr>
@@ -13413,7 +13413,7 @@
           <p:cNvPr id="5" name="Chart">
             <a:extLst xmlns:a="http://schemas.openxmlformats.org/drawingml/2006/main">
               <a:ext uri="{FF2B5EF4-FFF2-40B4-BE49-F238E27FC236}">
-                <a16:creationId xmlns:a16="http://schemas.microsoft.com/office/drawing/2014/main" id="{B3D9C430-D9B6-44E4-8E80-DEF25012B31D}"/>
+                <a16:creationId xmlns:a16="http://schemas.microsoft.com/office/drawing/2014/main" id="{098E3CBE-17AF-4B18-89E8-379A82A1EF97}"/>
               </a:ext>
             </a:extLst>
           </p:cNvPr>
@@ -13426,7 +13426,7 @@
         </p:xfrm>
         <a:graphic xmlns:a="http://schemas.openxmlformats.org/drawingml/2006/main">
           <a:graphicData uri="http://schemas.openxmlformats.org/drawingml/2006/chart">
-            <c:chart xmlns:r="http://schemas.openxmlformats.org/officeDocument/2006/relationships" xmlns:c="http://schemas.openxmlformats.org/drawingml/2006/chart" r:id="R2babef7576514e3a"/>
+            <c:chart xmlns:r="http://schemas.openxmlformats.org/officeDocument/2006/relationships" xmlns:c="http://schemas.openxmlformats.org/drawingml/2006/chart" r:id="R0fac1f932ffe4432"/>
           </a:graphicData>
         </a:graphic>
       </p:graphicFrame>
@@ -13435,7 +13435,7 @@
           <p:cNvPr id="6" name="">
             <a:extLst xmlns:a="http://schemas.openxmlformats.org/drawingml/2006/main">
               <a:ext uri="{FF2B5EF4-FFF2-40B4-BE49-F238E27FC236}">
-                <a16:creationId xmlns:a16="http://schemas.microsoft.com/office/drawing/2014/main" id="{782CCCB8-D537-44B7-B0DC-D2920E314B75}"/>
+                <a16:creationId xmlns:a16="http://schemas.microsoft.com/office/drawing/2014/main" id="{9E6827A2-0205-4ED9-AA82-4CD5043ED285}"/>
               </a:ext>
             </a:extLst>
           </p:cNvPr>
@@ -13503,7 +13503,7 @@
           <p:cNvPr id="7" name="">
             <a:extLst xmlns:a="http://schemas.openxmlformats.org/drawingml/2006/main">
               <a:ext uri="{FF2B5EF4-FFF2-40B4-BE49-F238E27FC236}">
-                <a16:creationId xmlns:a16="http://schemas.microsoft.com/office/drawing/2014/main" id="{9D0FC9D0-3D68-4EA5-AE3C-D3A2FC168073}"/>
+                <a16:creationId xmlns:a16="http://schemas.microsoft.com/office/drawing/2014/main" id="{68FA2221-A7AA-4B96-9C2D-9F68E05EE1B2}"/>
               </a:ext>
             </a:extLst>
           </p:cNvPr>
@@ -13594,7 +13594,7 @@
           <p:cNvPr id="8" name="">
             <a:extLst xmlns:a="http://schemas.openxmlformats.org/drawingml/2006/main">
               <a:ext uri="{FF2B5EF4-FFF2-40B4-BE49-F238E27FC236}">
-                <a16:creationId xmlns:a16="http://schemas.microsoft.com/office/drawing/2014/main" id="{60092563-87E5-49EA-9BF6-7E67A203B885}"/>
+                <a16:creationId xmlns:a16="http://schemas.microsoft.com/office/drawing/2014/main" id="{0623EB7B-936A-4298-9E2B-003620381F60}"/>
               </a:ext>
             </a:extLst>
           </p:cNvPr>
@@ -13708,7 +13708,7 @@
           <p:cNvPr id="9" name="">
             <a:extLst xmlns:a="http://schemas.openxmlformats.org/drawingml/2006/main">
               <a:ext uri="{FF2B5EF4-FFF2-40B4-BE49-F238E27FC236}">
-                <a16:creationId xmlns:a16="http://schemas.microsoft.com/office/drawing/2014/main" id="{4AE0B905-C577-41AF-B1DC-260080F9850C}"/>
+                <a16:creationId xmlns:a16="http://schemas.microsoft.com/office/drawing/2014/main" id="{802BAA52-3DE8-4691-9407-1B3ABC010653}"/>
               </a:ext>
             </a:extLst>
           </p:cNvPr>
@@ -13799,7 +13799,7 @@
           <p:cNvPr id="10" name="">
             <a:extLst xmlns:a="http://schemas.openxmlformats.org/drawingml/2006/main">
               <a:ext uri="{FF2B5EF4-FFF2-40B4-BE49-F238E27FC236}">
-                <a16:creationId xmlns:a16="http://schemas.microsoft.com/office/drawing/2014/main" id="{CD27D6A6-A91C-43BA-AB21-88F2511C71D7}"/>
+                <a16:creationId xmlns:a16="http://schemas.microsoft.com/office/drawing/2014/main" id="{37F07415-2287-4E94-B25C-1C8C49EC4018}"/>
               </a:ext>
             </a:extLst>
           </p:cNvPr>
@@ -13865,7 +13865,7 @@
     </p:spTree>
     <p:extLst>
       <p:ext uri="{BB962C8B-B14F-4D97-AF65-F5344CB8AC3E}">
-        <p14:creationId xmlns:p14="http://schemas.microsoft.com/office/powerpoint/2010/main" val="1680825444"/>
+        <p14:creationId xmlns:p14="http://schemas.microsoft.com/office/powerpoint/2010/main" val="1030681812"/>
       </p:ext>
     </p:extLst>
   </p:cSld>
@@ -13896,7 +13896,7 @@
           <p:cNvPr id="11" name="">
             <a:extLst xmlns:a="http://schemas.openxmlformats.org/drawingml/2006/main">
               <a:ext uri="{FF2B5EF4-FFF2-40B4-BE49-F238E27FC236}">
-                <a16:creationId xmlns:a16="http://schemas.microsoft.com/office/drawing/2014/main" id="{C6355814-8008-4638-A28D-E9AF41299AD0}"/>
+                <a16:creationId xmlns:a16="http://schemas.microsoft.com/office/drawing/2014/main" id="{7213C129-0FD3-4EEB-B18E-D1A6E1A532E9}"/>
               </a:ext>
             </a:extLst>
           </p:cNvPr>
@@ -13964,7 +13964,7 @@
           <p:cNvPr id="2" name="">
             <a:extLst xmlns:a="http://schemas.openxmlformats.org/drawingml/2006/main">
               <a:ext uri="{FF2B5EF4-FFF2-40B4-BE49-F238E27FC236}">
-                <a16:creationId xmlns:a16="http://schemas.microsoft.com/office/drawing/2014/main" id="{5AD18A5A-68AE-4B71-99B2-FE03A81C5434}"/>
+                <a16:creationId xmlns:a16="http://schemas.microsoft.com/office/drawing/2014/main" id="{C23F45A7-E0E8-43DB-85A4-D061B10B2147}"/>
               </a:ext>
             </a:extLst>
           </p:cNvPr>
@@ -13994,7 +13994,7 @@
           <p:cNvPr id="3" name="">
             <a:extLst xmlns:a="http://schemas.openxmlformats.org/drawingml/2006/main">
               <a:ext uri="{FF2B5EF4-FFF2-40B4-BE49-F238E27FC236}">
-                <a16:creationId xmlns:a16="http://schemas.microsoft.com/office/drawing/2014/main" id="{07DBD805-EAFF-46F4-A6D1-4E2524FCDF41}"/>
+                <a16:creationId xmlns:a16="http://schemas.microsoft.com/office/drawing/2014/main" id="{91799945-89E5-4F30-9B4E-C9DABFB3A044}"/>
               </a:ext>
             </a:extLst>
           </p:cNvPr>
@@ -14062,7 +14062,7 @@
           <p:cNvPr id="4" name="">
             <a:extLst xmlns:a="http://schemas.openxmlformats.org/drawingml/2006/main">
               <a:ext uri="{FF2B5EF4-FFF2-40B4-BE49-F238E27FC236}">
-                <a16:creationId xmlns:a16="http://schemas.microsoft.com/office/drawing/2014/main" id="{1B93B5DF-EA8C-4A64-9B49-792394E0587A}"/>
+                <a16:creationId xmlns:a16="http://schemas.microsoft.com/office/drawing/2014/main" id="{1A9D6BED-3CEE-4843-9CD5-FB6536C48151}"/>
               </a:ext>
             </a:extLst>
           </p:cNvPr>
@@ -14130,7 +14130,7 @@
           <p:cNvPr id="5" name="">
             <a:extLst xmlns:a="http://schemas.openxmlformats.org/drawingml/2006/main">
               <a:ext uri="{FF2B5EF4-FFF2-40B4-BE49-F238E27FC236}">
-                <a16:creationId xmlns:a16="http://schemas.microsoft.com/office/drawing/2014/main" id="{486DB167-D53C-4360-B7EC-8DFD8A1C5709}"/>
+                <a16:creationId xmlns:a16="http://schemas.microsoft.com/office/drawing/2014/main" id="{A24EA823-E5E8-4A00-AA07-DAB66C91FB44}"/>
               </a:ext>
             </a:extLst>
           </p:cNvPr>
@@ -14198,7 +14198,7 @@
           <p:cNvPr id="6" name="">
             <a:extLst xmlns:a="http://schemas.openxmlformats.org/drawingml/2006/main">
               <a:ext uri="{FF2B5EF4-FFF2-40B4-BE49-F238E27FC236}">
-                <a16:creationId xmlns:a16="http://schemas.microsoft.com/office/drawing/2014/main" id="{5522BF34-0945-4BC8-B5B9-34412C111704}"/>
+                <a16:creationId xmlns:a16="http://schemas.microsoft.com/office/drawing/2014/main" id="{4B1A8B13-856F-496F-9CDA-BB94B89C17B9}"/>
               </a:ext>
             </a:extLst>
           </p:cNvPr>
@@ -14266,7 +14266,7 @@
           <p:cNvPr id="7" name="">
             <a:extLst xmlns:a="http://schemas.openxmlformats.org/drawingml/2006/main">
               <a:ext uri="{FF2B5EF4-FFF2-40B4-BE49-F238E27FC236}">
-                <a16:creationId xmlns:a16="http://schemas.microsoft.com/office/drawing/2014/main" id="{DF7959A4-0843-4245-9FB5-D69E4D1869F2}"/>
+                <a16:creationId xmlns:a16="http://schemas.microsoft.com/office/drawing/2014/main" id="{A7E7D8FA-F0DC-45CB-B928-D4CC405385BE}"/>
               </a:ext>
             </a:extLst>
           </p:cNvPr>
@@ -14334,7 +14334,7 @@
           <p:cNvPr id="8" name="">
             <a:extLst xmlns:a="http://schemas.openxmlformats.org/drawingml/2006/main">
               <a:ext uri="{FF2B5EF4-FFF2-40B4-BE49-F238E27FC236}">
-                <a16:creationId xmlns:a16="http://schemas.microsoft.com/office/drawing/2014/main" id="{53B9FDF5-4F49-4157-A7FB-DDE854056AE7}"/>
+                <a16:creationId xmlns:a16="http://schemas.microsoft.com/office/drawing/2014/main" id="{AD6D113A-BEA1-4FFE-B191-D1F1E89D723F}"/>
               </a:ext>
             </a:extLst>
           </p:cNvPr>
@@ -14659,7 +14659,7 @@
           <p:cNvPr id="9" name="Chart">
             <a:extLst xmlns:a="http://schemas.openxmlformats.org/drawingml/2006/main">
               <a:ext uri="{FF2B5EF4-FFF2-40B4-BE49-F238E27FC236}">
-                <a16:creationId xmlns:a16="http://schemas.microsoft.com/office/drawing/2014/main" id="{5363D69C-6092-436F-9199-473448A7D8B0}"/>
+                <a16:creationId xmlns:a16="http://schemas.microsoft.com/office/drawing/2014/main" id="{2FBF7443-34B8-4170-9ED3-2C218FCC8F68}"/>
               </a:ext>
             </a:extLst>
           </p:cNvPr>
@@ -14672,7 +14672,7 @@
         </p:xfrm>
         <a:graphic xmlns:a="http://schemas.openxmlformats.org/drawingml/2006/main">
           <a:graphicData uri="http://schemas.openxmlformats.org/drawingml/2006/chart">
-            <c:chart xmlns:r="http://schemas.openxmlformats.org/officeDocument/2006/relationships" xmlns:c="http://schemas.openxmlformats.org/drawingml/2006/chart" r:id="Rdd682a1f5c154b54"/>
+            <c:chart xmlns:r="http://schemas.openxmlformats.org/officeDocument/2006/relationships" xmlns:c="http://schemas.openxmlformats.org/drawingml/2006/chart" r:id="R4ed20d2bf7834e52"/>
           </a:graphicData>
         </a:graphic>
       </p:graphicFrame>
@@ -14681,7 +14681,7 @@
           <p:cNvPr id="10" name="">
             <a:extLst xmlns:a="http://schemas.openxmlformats.org/drawingml/2006/main">
               <a:ext uri="{FF2B5EF4-FFF2-40B4-BE49-F238E27FC236}">
-                <a16:creationId xmlns:a16="http://schemas.microsoft.com/office/drawing/2014/main" id="{B83A8D2C-E350-4B6B-B25E-5F6FAB8F489B}"/>
+                <a16:creationId xmlns:a16="http://schemas.microsoft.com/office/drawing/2014/main" id="{40C7E5F4-1805-4FE5-8473-FDD00B6BAC37}"/>
               </a:ext>
             </a:extLst>
           </p:cNvPr>
@@ -14747,7 +14747,7 @@
     </p:spTree>
     <p:extLst>
       <p:ext uri="{BB962C8B-B14F-4D97-AF65-F5344CB8AC3E}">
-        <p14:creationId xmlns:p14="http://schemas.microsoft.com/office/powerpoint/2010/main" val="1173714822"/>
+        <p14:creationId xmlns:p14="http://schemas.microsoft.com/office/powerpoint/2010/main" val="1246393428"/>
       </p:ext>
     </p:extLst>
   </p:cSld>
@@ -14778,7 +14778,7 @@
           <p:cNvPr id="10" name="">
             <a:extLst xmlns:a="http://schemas.openxmlformats.org/drawingml/2006/main">
               <a:ext uri="{FF2B5EF4-FFF2-40B4-BE49-F238E27FC236}">
-                <a16:creationId xmlns:a16="http://schemas.microsoft.com/office/drawing/2014/main" id="{CE71E3F1-03B8-4087-BC96-62555B33ACDA}"/>
+                <a16:creationId xmlns:a16="http://schemas.microsoft.com/office/drawing/2014/main" id="{3AD9158E-4DCA-4006-8716-44DEDD160A6E}"/>
               </a:ext>
             </a:extLst>
           </p:cNvPr>
@@ -14846,7 +14846,7 @@
           <p:cNvPr id="2" name="">
             <a:extLst xmlns:a="http://schemas.openxmlformats.org/drawingml/2006/main">
               <a:ext uri="{FF2B5EF4-FFF2-40B4-BE49-F238E27FC236}">
-                <a16:creationId xmlns:a16="http://schemas.microsoft.com/office/drawing/2014/main" id="{58C1DEFE-A877-4D3D-90A5-066B3A2F721D}"/>
+                <a16:creationId xmlns:a16="http://schemas.microsoft.com/office/drawing/2014/main" id="{47EAB128-6AD6-4873-8EC8-BB54BC374534}"/>
               </a:ext>
             </a:extLst>
           </p:cNvPr>
@@ -14876,7 +14876,7 @@
           <p:cNvPr id="3" name="">
             <a:extLst xmlns:a="http://schemas.openxmlformats.org/drawingml/2006/main">
               <a:ext uri="{FF2B5EF4-FFF2-40B4-BE49-F238E27FC236}">
-                <a16:creationId xmlns:a16="http://schemas.microsoft.com/office/drawing/2014/main" id="{8B69D1EA-F22D-4347-92C7-6BEB18680DA5}"/>
+                <a16:creationId xmlns:a16="http://schemas.microsoft.com/office/drawing/2014/main" id="{F1F4FE91-76AC-451D-95A4-01131EF46C29}"/>
               </a:ext>
             </a:extLst>
           </p:cNvPr>
@@ -14944,7 +14944,7 @@
           <p:cNvPr id="4" name="">
             <a:extLst xmlns:a="http://schemas.openxmlformats.org/drawingml/2006/main">
               <a:ext uri="{FF2B5EF4-FFF2-40B4-BE49-F238E27FC236}">
-                <a16:creationId xmlns:a16="http://schemas.microsoft.com/office/drawing/2014/main" id="{4B10B0B0-8CA9-498D-9026-E3F12D9FC5CC}"/>
+                <a16:creationId xmlns:a16="http://schemas.microsoft.com/office/drawing/2014/main" id="{229DCC09-EB5D-4584-A0B9-B38518ABBDF3}"/>
               </a:ext>
             </a:extLst>
           </p:cNvPr>
@@ -15012,7 +15012,7 @@
           <p:cNvPr id="5" name="">
             <a:extLst xmlns:a="http://schemas.openxmlformats.org/drawingml/2006/main">
               <a:ext uri="{FF2B5EF4-FFF2-40B4-BE49-F238E27FC236}">
-                <a16:creationId xmlns:a16="http://schemas.microsoft.com/office/drawing/2014/main" id="{9D0AD9AF-0FDD-4BC1-8C9F-B72C6B0094F3}"/>
+                <a16:creationId xmlns:a16="http://schemas.microsoft.com/office/drawing/2014/main" id="{725B5694-DCE9-4F1B-BE46-A20A0CEF7833}"/>
               </a:ext>
             </a:extLst>
           </p:cNvPr>
@@ -15103,7 +15103,7 @@
           <p:cNvPr id="6" name="">
             <a:extLst xmlns:a="http://schemas.openxmlformats.org/drawingml/2006/main">
               <a:ext uri="{FF2B5EF4-FFF2-40B4-BE49-F238E27FC236}">
-                <a16:creationId xmlns:a16="http://schemas.microsoft.com/office/drawing/2014/main" id="{A263527C-2B1D-4060-9AB7-ED3CDB1DF405}"/>
+                <a16:creationId xmlns:a16="http://schemas.microsoft.com/office/drawing/2014/main" id="{932CAA3F-1286-4D08-8B77-2F01F3D3C264}"/>
               </a:ext>
             </a:extLst>
           </p:cNvPr>
@@ -15502,7 +15502,7 @@
           <p:cNvPr id="7" name="">
             <a:extLst xmlns:a="http://schemas.openxmlformats.org/drawingml/2006/main">
               <a:ext uri="{FF2B5EF4-FFF2-40B4-BE49-F238E27FC236}">
-                <a16:creationId xmlns:a16="http://schemas.microsoft.com/office/drawing/2014/main" id="{9A87AEFA-2629-4772-8DC6-E4E714049FC7}"/>
+                <a16:creationId xmlns:a16="http://schemas.microsoft.com/office/drawing/2014/main" id="{216F178C-A743-4FB6-B10A-DA425CB91F37}"/>
               </a:ext>
             </a:extLst>
           </p:cNvPr>
@@ -15570,7 +15570,7 @@
           <p:cNvPr id="8" name="">
             <a:extLst xmlns:a="http://schemas.openxmlformats.org/drawingml/2006/main">
               <a:ext uri="{FF2B5EF4-FFF2-40B4-BE49-F238E27FC236}">
-                <a16:creationId xmlns:a16="http://schemas.microsoft.com/office/drawing/2014/main" id="{FE198AE4-82D8-4DD5-9D26-012851328F15}"/>
+                <a16:creationId xmlns:a16="http://schemas.microsoft.com/office/drawing/2014/main" id="{690D2AF8-1B66-4207-80D3-848186D20A24}"/>
               </a:ext>
             </a:extLst>
           </p:cNvPr>
@@ -15684,7 +15684,7 @@
           <p:cNvPr id="9" name="">
             <a:extLst xmlns:a="http://schemas.openxmlformats.org/drawingml/2006/main">
               <a:ext uri="{FF2B5EF4-FFF2-40B4-BE49-F238E27FC236}">
-                <a16:creationId xmlns:a16="http://schemas.microsoft.com/office/drawing/2014/main" id="{4D06AF03-A7AC-4E0E-AC75-D2A50C2E240B}"/>
+                <a16:creationId xmlns:a16="http://schemas.microsoft.com/office/drawing/2014/main" id="{C946D760-80D2-49C0-A51C-6BF12F298B30}"/>
               </a:ext>
             </a:extLst>
           </p:cNvPr>
@@ -15750,7 +15750,7 @@
     </p:spTree>
     <p:extLst>
       <p:ext uri="{BB962C8B-B14F-4D97-AF65-F5344CB8AC3E}">
-        <p14:creationId xmlns:p14="http://schemas.microsoft.com/office/powerpoint/2010/main" val="827642912"/>
+        <p14:creationId xmlns:p14="http://schemas.microsoft.com/office/powerpoint/2010/main" val="732997816"/>
       </p:ext>
     </p:extLst>
   </p:cSld>

</xml_diff>